<commit_message>
Update Slide 3 with new vector architecture and team repo FUTURISTICS
</commit_message>
<xml_diff>
--- a/SPECTRA_SIH_2026_Strict_Template_Presentation.pptx
+++ b/SPECTRA_SIH_2026_Strict_Template_Presentation.pptx
@@ -5,7 +5,7 @@
     <p:sldMasterId id="2147483648" r:id="rId1"/>
   </p:sldMasterIdLst>
   <p:notesMasterIdLst>
-    <p:notesMasterId r:id="rId8"/>
+    <p:notesMasterId r:id="rId9"/>
   </p:notesMasterIdLst>
   <p:sldIdLst>
     <p:sldId id="291" r:id="rId2"/>
@@ -261,7 +261,7 @@
             <a:fld id="{C4D5ADD5-2BBC-4A94-8F86-D9013941F742}" type="datetimeFigureOut">
               <a:rPr lang="en-US"/>
               <a:pPr/>
-              <a:t>9/22/2026</a:t>
+              <a:t>6/2/2026</a:t>
             </a:fld>
             <a:endParaRPr lang="en-US"/>
           </a:p>
@@ -1534,7 +1534,7 @@
           <a:p>
             <a:fld id="{E60792E3-D524-454C-8AFD-A91972900BCB}" type="datetime1">
               <a:rPr lang="en-US" smtClean="0"/>
-              <a:t>9/22/2026</a:t>
+              <a:t>6/2/2026</a:t>
             </a:fld>
             <a:endParaRPr lang="en-US"/>
           </a:p>
@@ -1716,7 +1716,7 @@
           <a:p>
             <a:fld id="{053C3A68-6922-42D3-8905-ECC2D82A3469}" type="datetime1">
               <a:rPr lang="en-US" smtClean="0"/>
-              <a:t>9/22/2026</a:t>
+              <a:t>6/2/2026</a:t>
             </a:fld>
             <a:endParaRPr lang="en-US"/>
           </a:p>
@@ -1908,7 +1908,7 @@
           <a:p>
             <a:fld id="{CB69E9F4-7604-4950-A8B2-8ACDEDB1506E}" type="datetime1">
               <a:rPr lang="en-US" smtClean="0"/>
-              <a:t>9/22/2026</a:t>
+              <a:t>6/2/2026</a:t>
             </a:fld>
             <a:endParaRPr lang="en-US"/>
           </a:p>
@@ -2090,7 +2090,7 @@
           <a:p>
             <a:fld id="{708B7524-32A2-4C20-A58C-BC3BAA1042FC}" type="datetime1">
               <a:rPr lang="en-US" smtClean="0"/>
-              <a:t>9/22/2026</a:t>
+              <a:t>6/2/2026</a:t>
             </a:fld>
             <a:endParaRPr lang="en-US"/>
           </a:p>
@@ -2349,7 +2349,7 @@
           <a:p>
             <a:fld id="{1E994447-D6B2-43BB-A877-57F1A267B999}" type="datetime1">
               <a:rPr lang="en-US" smtClean="0"/>
-              <a:t>9/22/2026</a:t>
+              <a:t>6/2/2026</a:t>
             </a:fld>
             <a:endParaRPr lang="en-US"/>
           </a:p>
@@ -2648,7 +2648,7 @@
           <a:p>
             <a:fld id="{68920E16-BD35-483C-AA6B-346FC7E46DEA}" type="datetime1">
               <a:rPr lang="en-US" smtClean="0"/>
-              <a:t>9/22/2026</a:t>
+              <a:t>6/2/2026</a:t>
             </a:fld>
             <a:endParaRPr lang="en-US"/>
           </a:p>
@@ -3081,7 +3081,7 @@
           <a:p>
             <a:fld id="{2FEAC6F8-5103-4FC0-A69E-5C6AE6469DA8}" type="datetime1">
               <a:rPr lang="en-US" smtClean="0"/>
-              <a:t>9/22/2026</a:t>
+              <a:t>6/2/2026</a:t>
             </a:fld>
             <a:endParaRPr lang="en-US"/>
           </a:p>
@@ -3212,7 +3212,7 @@
           <a:p>
             <a:fld id="{C60C6921-0627-4C8F-83D5-0CF936D2FFDD}" type="datetime1">
               <a:rPr lang="en-US" smtClean="0"/>
-              <a:t>9/22/2026</a:t>
+              <a:t>6/2/2026</a:t>
             </a:fld>
             <a:endParaRPr lang="en-US"/>
           </a:p>
@@ -3321,7 +3321,7 @@
           <a:p>
             <a:fld id="{2FF08AD7-8103-40F8-983C-E2BA6BB9CBE0}" type="datetime1">
               <a:rPr lang="en-US" smtClean="0"/>
-              <a:t>9/22/2026</a:t>
+              <a:t>6/2/2026</a:t>
             </a:fld>
             <a:endParaRPr lang="en-US"/>
           </a:p>
@@ -3610,7 +3610,7 @@
           <a:p>
             <a:fld id="{DF8C06B4-9380-4A4D-AF49-A3596E17DAF5}" type="datetime1">
               <a:rPr lang="en-US" smtClean="0"/>
-              <a:t>9/22/2026</a:t>
+              <a:t>6/2/2026</a:t>
             </a:fld>
             <a:endParaRPr lang="en-US"/>
           </a:p>
@@ -3879,7 +3879,7 @@
           <a:p>
             <a:fld id="{EF7FDEF1-C582-4E22-9E77-D68326471F28}" type="datetime1">
               <a:rPr lang="en-US" smtClean="0"/>
-              <a:t>9/22/2026</a:t>
+              <a:t>6/2/2026</a:t>
             </a:fld>
             <a:endParaRPr lang="en-US"/>
           </a:p>
@@ -4122,7 +4122,7 @@
           <a:p>
             <a:fld id="{780A9602-A9A9-453F-AEF1-37B5837E02CD}" type="datetime1">
               <a:rPr lang="en-US" smtClean="0"/>
-              <a:t>9/22/2026</a:t>
+              <a:t>6/2/2026</a:t>
             </a:fld>
             <a:endParaRPr lang="en-US"/>
           </a:p>
@@ -4673,7 +4673,7 @@
                 <a16:creationId xmlns:a16="http://schemas.microsoft.com/office/drawing/2014/main" id="{3E443FD7-A66B-4AA0-872D-B088B9BC5F17}"/>
               </a:ext>
               <a:ext uri="{C183D7F6-B498-43B3-948B-1728B52AA6E4}">
-                <adec:decorative xmlns:adec="http://schemas.microsoft.com/office/drawing/2017/decorative" val="1"/>
+                <adec:decorative xmlns:adec="http://schemas.microsoft.com/office/drawing/2017/decorative" xmlns="" val="1"/>
               </a:ext>
             </a:extLst>
           </p:cNvPr>
@@ -4733,7 +4733,7 @@
                 <a16:creationId xmlns:a16="http://schemas.microsoft.com/office/drawing/2014/main" id="{C04BE0EF-3561-49B4-9A29-F283168A91C7}"/>
               </a:ext>
               <a:ext uri="{C183D7F6-B498-43B3-948B-1728B52AA6E4}">
-                <adec:decorative xmlns:adec="http://schemas.microsoft.com/office/drawing/2017/decorative" val="1"/>
+                <adec:decorative xmlns:adec="http://schemas.microsoft.com/office/drawing/2017/decorative" xmlns="" val="1"/>
               </a:ext>
             </a:extLst>
           </p:cNvPr>
@@ -5644,7 +5644,16 @@
                 </a:solidFill>
                 <a:latin typeface="Times New Roman"/>
               </a:rPr>
-              <a:t>• Problem Statement ID –</a:t>
+              <a:t>• </a:t>
+            </a:r>
+            <a:r>
+              <a:rPr sz="1800" b="1">
+                <a:solidFill>
+                  <a:srgbClr val="0F172A"/>
+                </a:solidFill>
+                <a:latin typeface="Times New Roman"/>
+              </a:rPr>
+              <a:t>Problem Statement ID –</a:t>
             </a:r>
             <a:r>
               <a:rPr sz="1800" b="0">
@@ -5673,7 +5682,16 @@
                 </a:solidFill>
                 <a:latin typeface="Times New Roman"/>
               </a:rPr>
-              <a:t>• Problem Statement Title-</a:t>
+              <a:t>• </a:t>
+            </a:r>
+            <a:r>
+              <a:rPr sz="1800" b="1">
+                <a:solidFill>
+                  <a:srgbClr val="0F172A"/>
+                </a:solidFill>
+                <a:latin typeface="Times New Roman"/>
+              </a:rPr>
+              <a:t>Problem Statement Title-</a:t>
             </a:r>
             <a:r>
               <a:rPr sz="1800" b="0">
@@ -5701,7 +5719,16 @@
                 </a:solidFill>
                 <a:latin typeface="Times New Roman"/>
               </a:rPr>
-              <a:t>• Theme-</a:t>
+              <a:t>• </a:t>
+            </a:r>
+            <a:r>
+              <a:rPr sz="1800" b="1">
+                <a:solidFill>
+                  <a:srgbClr val="0F172A"/>
+                </a:solidFill>
+                <a:latin typeface="Times New Roman"/>
+              </a:rPr>
+              <a:t>Theme-</a:t>
             </a:r>
             <a:r>
               <a:rPr sz="1800" b="0">
@@ -5729,7 +5756,16 @@
                 </a:solidFill>
                 <a:latin typeface="Times New Roman"/>
               </a:rPr>
-              <a:t>• PS Category-</a:t>
+              <a:t>• </a:t>
+            </a:r>
+            <a:r>
+              <a:rPr sz="1800" b="1">
+                <a:solidFill>
+                  <a:srgbClr val="0F172A"/>
+                </a:solidFill>
+                <a:latin typeface="Times New Roman"/>
+              </a:rPr>
+              <a:t>PS Category-</a:t>
             </a:r>
             <a:r>
               <a:rPr sz="1800" b="0">
@@ -5757,7 +5793,16 @@
                 </a:solidFill>
                 <a:latin typeface="Times New Roman"/>
               </a:rPr>
-              <a:t>• Team ID-</a:t>
+              <a:t>• </a:t>
+            </a:r>
+            <a:r>
+              <a:rPr sz="1800" b="1">
+                <a:solidFill>
+                  <a:srgbClr val="0F172A"/>
+                </a:solidFill>
+                <a:latin typeface="Times New Roman"/>
+              </a:rPr>
+              <a:t>Team ID-</a:t>
             </a:r>
             <a:r>
               <a:rPr sz="1800" b="0">
@@ -5785,7 +5830,16 @@
                 </a:solidFill>
                 <a:latin typeface="Times New Roman"/>
               </a:rPr>
-              <a:t>• Team Name (Registered on portal)-</a:t>
+              <a:t>• </a:t>
+            </a:r>
+            <a:r>
+              <a:rPr sz="1800" b="1">
+                <a:solidFill>
+                  <a:srgbClr val="0F172A"/>
+                </a:solidFill>
+                <a:latin typeface="Times New Roman"/>
+              </a:rPr>
+              <a:t>Team Name (Registered on portal)-</a:t>
             </a:r>
             <a:r>
               <a:rPr sz="1800" b="0">
@@ -5932,7 +5986,7 @@
           <a:bodyPr/>
           <a:lstStyle/>
           <a:p>
-            <a:pPr algn="ctr" eaLnBrk="1" hangingPunct="1"/>
+            <a:pPr eaLnBrk="1" hangingPunct="1" algn="ctr"/>
             <a:r>
               <a:rPr sz="2400" b="1">
                 <a:solidFill>
@@ -6031,7 +6085,7 @@
                 <a16:creationId xmlns:a16="http://schemas.microsoft.com/office/drawing/2014/main" id="{5DBCE864-823D-4A13-9607-5DA1F0ED5FB8}"/>
               </a:ext>
               <a:ext uri="{C183D7F6-B498-43B3-948B-1728B52AA6E4}">
-                <adec:decorative xmlns:adec="http://schemas.microsoft.com/office/drawing/2017/decorative" val="0"/>
+                <adec:decorative xmlns:adec="http://schemas.microsoft.com/office/drawing/2017/decorative" xmlns="" val="0"/>
               </a:ext>
             </a:extLst>
           </p:cNvPr>
@@ -6070,7 +6124,7 @@
           </a:fontRef>
         </p:style>
         <p:txBody>
-          <a:bodyPr wrap="none" lIns="0" tIns="0" rIns="0" bIns="0" rtlCol="0" anchor="ctr"/>
+          <a:bodyPr rtlCol="0" anchor="ctr" wrap="none" lIns="0" rIns="0" tIns="0" bIns="0"/>
           <a:lstStyle/>
           <a:p>
             <a:pPr algn="ctr"/>
@@ -6157,7 +6211,6 @@
           <a:lstStyle/>
           <a:p>
             <a:pPr algn="ctr"/>
-            <a:endParaRPr/>
           </a:p>
         </p:txBody>
       </p:sp>
@@ -6203,7 +6256,6 @@
           <a:lstStyle/>
           <a:p>
             <a:pPr algn="ctr"/>
-            <a:endParaRPr/>
           </a:p>
         </p:txBody>
       </p:sp>
@@ -6224,13 +6276,13 @@
           <a:noFill/>
         </p:spPr>
         <p:txBody>
-          <a:bodyPr wrap="square" lIns="0" tIns="0" rIns="0" bIns="0">
+          <a:bodyPr wrap="square" lIns="0" rIns="0" tIns="0" bIns="0">
             <a:spAutoFit/>
           </a:bodyPr>
           <a:lstStyle/>
           <a:p>
             <a:r>
-              <a:rPr sz="1300" b="1">
+              <a:rPr sz="1500" b="1">
                 <a:solidFill>
                   <a:srgbClr val="1E3A8A"/>
                 </a:solidFill>
@@ -6246,7 +6298,7 @@
               </a:spcBef>
             </a:pPr>
             <a:r>
-              <a:rPr sz="1300">
+              <a:rPr sz="1120">
                 <a:solidFill>
                   <a:srgbClr val="0F172A"/>
                 </a:solidFill>
@@ -6262,7 +6314,7 @@
               </a:spcBef>
             </a:pPr>
             <a:r>
-              <a:rPr sz="1300">
+              <a:rPr sz="1120">
                 <a:solidFill>
                   <a:srgbClr val="0F172A"/>
                 </a:solidFill>
@@ -6278,7 +6330,7 @@
               </a:spcBef>
             </a:pPr>
             <a:r>
-              <a:rPr sz="1300">
+              <a:rPr sz="1120">
                 <a:solidFill>
                   <a:srgbClr val="0F172A"/>
                 </a:solidFill>
@@ -6329,7 +6381,6 @@
           <a:lstStyle/>
           <a:p>
             <a:pPr algn="ctr"/>
-            <a:endParaRPr/>
           </a:p>
         </p:txBody>
       </p:sp>
@@ -6375,7 +6426,6 @@
           <a:lstStyle/>
           <a:p>
             <a:pPr algn="ctr"/>
-            <a:endParaRPr/>
           </a:p>
         </p:txBody>
       </p:sp>
@@ -6388,7 +6438,7 @@
         <p:spPr>
           <a:xfrm>
             <a:off x="6400800" y="1325880"/>
-            <a:ext cx="5074920" cy="2054409"/>
+            <a:ext cx="5074920" cy="2148839"/>
           </a:xfrm>
           <a:prstGeom prst="rect">
             <a:avLst/>
@@ -6396,13 +6446,13 @@
           <a:noFill/>
         </p:spPr>
         <p:txBody>
-          <a:bodyPr wrap="square" lIns="0" tIns="0" rIns="0" bIns="0">
+          <a:bodyPr wrap="square" lIns="0" rIns="0" tIns="0" bIns="0">
             <a:spAutoFit/>
           </a:bodyPr>
           <a:lstStyle/>
           <a:p>
             <a:r>
-              <a:rPr sz="1400" b="1">
+              <a:rPr sz="1500" b="1">
                 <a:solidFill>
                   <a:srgbClr val="1E3A8A"/>
                 </a:solidFill>
@@ -6418,7 +6468,7 @@
               </a:spcBef>
             </a:pPr>
             <a:r>
-              <a:rPr sz="1400">
+              <a:rPr sz="1120">
                 <a:solidFill>
                   <a:srgbClr val="0F172A"/>
                 </a:solidFill>
@@ -6434,7 +6484,7 @@
               </a:spcBef>
             </a:pPr>
             <a:r>
-              <a:rPr sz="1400">
+              <a:rPr sz="1120">
                 <a:solidFill>
                   <a:srgbClr val="0F172A"/>
                 </a:solidFill>
@@ -6450,7 +6500,7 @@
               </a:spcBef>
             </a:pPr>
             <a:r>
-              <a:rPr sz="1400">
+              <a:rPr sz="1120">
                 <a:solidFill>
                   <a:srgbClr val="0F172A"/>
                 </a:solidFill>
@@ -6501,7 +6551,6 @@
           <a:lstStyle/>
           <a:p>
             <a:pPr algn="ctr"/>
-            <a:endParaRPr/>
           </a:p>
         </p:txBody>
       </p:sp>
@@ -6547,7 +6596,6 @@
           <a:lstStyle/>
           <a:p>
             <a:pPr algn="ctr"/>
-            <a:endParaRPr/>
           </a:p>
         </p:txBody>
       </p:sp>
@@ -6560,7 +6608,7 @@
         <p:spPr>
           <a:xfrm>
             <a:off x="731520" y="3840479"/>
-            <a:ext cx="5074920" cy="2231380"/>
+            <a:ext cx="5074920" cy="2148839"/>
           </a:xfrm>
           <a:prstGeom prst="rect">
             <a:avLst/>
@@ -6568,13 +6616,13 @@
           <a:noFill/>
         </p:spPr>
         <p:txBody>
-          <a:bodyPr wrap="square" lIns="0" tIns="0" rIns="0" bIns="0">
+          <a:bodyPr wrap="square" lIns="0" rIns="0" tIns="0" bIns="0">
             <a:spAutoFit/>
           </a:bodyPr>
           <a:lstStyle/>
           <a:p>
             <a:r>
-              <a:rPr sz="1400" b="1">
+              <a:rPr sz="1500" b="1">
                 <a:solidFill>
                   <a:srgbClr val="1E3A8A"/>
                 </a:solidFill>
@@ -6590,7 +6638,7 @@
               </a:spcBef>
             </a:pPr>
             <a:r>
-              <a:rPr sz="1400">
+              <a:rPr sz="1050">
                 <a:solidFill>
                   <a:srgbClr val="0F172A"/>
                 </a:solidFill>
@@ -6606,7 +6654,7 @@
               </a:spcBef>
             </a:pPr>
             <a:r>
-              <a:rPr sz="1400">
+              <a:rPr sz="1050">
                 <a:solidFill>
                   <a:srgbClr val="0F172A"/>
                 </a:solidFill>
@@ -6622,7 +6670,7 @@
               </a:spcBef>
             </a:pPr>
             <a:r>
-              <a:rPr sz="1400">
+              <a:rPr sz="1050">
                 <a:solidFill>
                   <a:srgbClr val="0F172A"/>
                 </a:solidFill>
@@ -6673,7 +6721,6 @@
           <a:lstStyle/>
           <a:p>
             <a:pPr algn="ctr"/>
-            <a:endParaRPr/>
           </a:p>
         </p:txBody>
       </p:sp>
@@ -6719,7 +6766,6 @@
           <a:lstStyle/>
           <a:p>
             <a:pPr algn="ctr"/>
-            <a:endParaRPr/>
           </a:p>
         </p:txBody>
       </p:sp>
@@ -6740,13 +6786,13 @@
           <a:noFill/>
         </p:spPr>
         <p:txBody>
-          <a:bodyPr wrap="square" lIns="0" tIns="0" rIns="0" bIns="0">
+          <a:bodyPr wrap="square" lIns="0" rIns="0" tIns="0" bIns="0">
             <a:spAutoFit/>
           </a:bodyPr>
           <a:lstStyle/>
           <a:p>
             <a:r>
-              <a:rPr sz="1200" b="1">
+              <a:rPr sz="1500" b="1">
                 <a:solidFill>
                   <a:srgbClr val="1E3A8A"/>
                 </a:solidFill>
@@ -6762,7 +6808,7 @@
               </a:spcBef>
             </a:pPr>
             <a:r>
-              <a:rPr sz="1200">
+              <a:rPr sz="1050">
                 <a:solidFill>
                   <a:srgbClr val="0F172A"/>
                 </a:solidFill>
@@ -6778,7 +6824,7 @@
               </a:spcBef>
             </a:pPr>
             <a:r>
-              <a:rPr sz="1200">
+              <a:rPr sz="1050">
                 <a:solidFill>
                   <a:srgbClr val="0F172A"/>
                 </a:solidFill>
@@ -6794,7 +6840,7 @@
               </a:spcBef>
             </a:pPr>
             <a:r>
-              <a:rPr sz="1200">
+              <a:rPr sz="1050">
                 <a:solidFill>
                   <a:srgbClr val="0F172A"/>
                 </a:solidFill>
@@ -6810,7 +6856,7 @@
               </a:spcBef>
             </a:pPr>
             <a:r>
-              <a:rPr sz="1200">
+              <a:rPr sz="1050">
                 <a:solidFill>
                   <a:srgbClr val="0F172A"/>
                 </a:solidFill>
@@ -6930,7 +6976,7 @@
           <a:bodyPr/>
           <a:lstStyle/>
           <a:p>
-            <a:pPr algn="ctr" eaLnBrk="1" hangingPunct="1"/>
+            <a:pPr eaLnBrk="1" hangingPunct="1" algn="ctr"/>
             <a:r>
               <a:rPr sz="2400" b="1">
                 <a:solidFill>
@@ -7029,7 +7075,7 @@
                 <a16:creationId xmlns:a16="http://schemas.microsoft.com/office/drawing/2014/main" id="{5DBCE864-823D-4A13-9607-5DA1F0ED5FB8}"/>
               </a:ext>
               <a:ext uri="{C183D7F6-B498-43B3-948B-1728B52AA6E4}">
-                <adec:decorative xmlns:adec="http://schemas.microsoft.com/office/drawing/2017/decorative" val="0"/>
+                <adec:decorative xmlns:adec="http://schemas.microsoft.com/office/drawing/2017/decorative" xmlns="" val="0"/>
               </a:ext>
             </a:extLst>
           </p:cNvPr>
@@ -7068,7 +7114,7 @@
           </a:fontRef>
         </p:style>
         <p:txBody>
-          <a:bodyPr wrap="none" lIns="0" tIns="0" rIns="0" bIns="0" rtlCol="0" anchor="ctr"/>
+          <a:bodyPr rtlCol="0" anchor="ctr" wrap="none" lIns="0" rIns="0" tIns="0" bIns="0"/>
           <a:lstStyle/>
           <a:p>
             <a:pPr algn="ctr"/>
@@ -7117,25 +7163,23 @@
       </p:pic>
       <p:sp>
         <p:nvSpPr>
-          <p:cNvPr id="17411" name="Rounded Rectangle 17410"/>
+          <p:cNvPr id="17410" name="Rounded Rectangle 17409"/>
           <p:cNvSpPr/>
           <p:nvPr/>
         </p:nvSpPr>
         <p:spPr>
           <a:xfrm>
-            <a:off x="320040" y="1031214"/>
-            <a:ext cx="11430000" cy="2674920"/>
+            <a:off x="365760" y="1005840"/>
+            <a:ext cx="11430000" cy="3840480"/>
           </a:xfrm>
           <a:prstGeom prst="roundRect">
             <a:avLst/>
           </a:prstGeom>
           <a:solidFill>
-            <a:srgbClr val="F8FAFC"/>
+            <a:srgbClr val="E2E8F0"/>
           </a:solidFill>
-          <a:ln w="19050">
-            <a:solidFill>
-              <a:srgbClr val="94A3B8"/>
-            </a:solidFill>
+          <a:ln>
+            <a:noFill/>
           </a:ln>
         </p:spPr>
         <p:style>
@@ -7157,78 +7201,19 @@
           <a:lstStyle/>
           <a:p>
             <a:pPr algn="ctr"/>
-            <a:endParaRPr/>
-          </a:p>
-        </p:txBody>
-      </p:sp>
-      <p:sp>
-        <p:nvSpPr>
-          <p:cNvPr id="17412" name="TextBox 17411"/>
-          <p:cNvSpPr txBox="1"/>
-          <p:nvPr/>
-        </p:nvSpPr>
-        <p:spPr>
-          <a:xfrm>
-            <a:off x="482104" y="1005840"/>
-            <a:ext cx="10972800" cy="320040"/>
-          </a:xfrm>
-          <a:prstGeom prst="rect">
-            <a:avLst/>
-          </a:prstGeom>
-          <a:noFill/>
-        </p:spPr>
-        <p:txBody>
-          <a:bodyPr wrap="none">
-            <a:spAutoFit/>
-          </a:bodyPr>
-          <a:lstStyle/>
-          <a:p>
-            <a:r>
-              <a:rPr sz="1500" b="1" dirty="0">
-                <a:solidFill>
-                  <a:srgbClr val="1E3A8A"/>
-                </a:solidFill>
-                <a:latin typeface="Times New Roman"/>
-              </a:rPr>
-              <a:t>System Architecture</a:t>
-            </a:r>
-          </a:p>
-        </p:txBody>
-      </p:sp>
-      <p:pic>
-        <p:nvPicPr>
-          <p:cNvPr id="17413" name="Picture 17412" descr="system_architecture_hd.png"/>
-          <p:cNvPicPr>
-            <a:picLocks noChangeAspect="1"/>
-          </p:cNvPicPr>
-          <p:nvPr/>
-        </p:nvPicPr>
-        <p:blipFill>
-          <a:blip r:embed="rId4"/>
-          <a:stretch>
-            <a:fillRect/>
-          </a:stretch>
-        </p:blipFill>
-        <p:spPr>
-          <a:xfrm>
-            <a:off x="762000" y="1301581"/>
-            <a:ext cx="10942320" cy="2432304"/>
-          </a:xfrm>
-          <a:prstGeom prst="rect">
-            <a:avLst/>
-          </a:prstGeom>
-        </p:spPr>
-      </p:pic>
-      <p:sp>
-        <p:nvSpPr>
-          <p:cNvPr id="17415" name="Rounded Rectangle 17414"/>
+          </a:p>
+        </p:txBody>
+      </p:sp>
+      <p:sp>
+        <p:nvSpPr>
+          <p:cNvPr id="17411" name="Rounded Rectangle 17410"/>
           <p:cNvSpPr/>
           <p:nvPr/>
         </p:nvSpPr>
         <p:spPr>
           <a:xfrm>
-            <a:off x="213360" y="4169664"/>
-            <a:ext cx="3657600" cy="1944221"/>
+            <a:off x="320040" y="960120"/>
+            <a:ext cx="11430000" cy="3840480"/>
           </a:xfrm>
           <a:prstGeom prst="roundRect">
             <a:avLst/>
@@ -7261,20 +7246,19 @@
           <a:lstStyle/>
           <a:p>
             <a:pPr algn="ctr"/>
-            <a:endParaRPr/>
-          </a:p>
-        </p:txBody>
-      </p:sp>
-      <p:sp>
-        <p:nvSpPr>
-          <p:cNvPr id="17416" name="TextBox 17415"/>
+          </a:p>
+        </p:txBody>
+      </p:sp>
+      <p:sp>
+        <p:nvSpPr>
+          <p:cNvPr id="17412" name="TextBox 17411"/>
           <p:cNvSpPr txBox="1"/>
           <p:nvPr/>
         </p:nvSpPr>
         <p:spPr>
           <a:xfrm>
-            <a:off x="350520" y="4286478"/>
-            <a:ext cx="3383280" cy="1431161"/>
+            <a:off x="457200" y="1005840"/>
+            <a:ext cx="10972800" cy="320040"/>
           </a:xfrm>
           <a:prstGeom prst="rect">
             <a:avLst/>
@@ -7282,212 +7266,66 @@
           <a:noFill/>
         </p:spPr>
         <p:txBody>
-          <a:bodyPr wrap="square" lIns="0" tIns="0" rIns="0" bIns="0">
+          <a:bodyPr wrap="none">
             <a:spAutoFit/>
           </a:bodyPr>
           <a:lstStyle/>
           <a:p>
             <a:r>
-              <a:rPr sz="1600" b="1" dirty="0">
+              <a:rPr sz="1500" b="1">
                 <a:solidFill>
                   <a:srgbClr val="1E3A8A"/>
                 </a:solidFill>
                 <a:latin typeface="Times New Roman"/>
               </a:rPr>
-              <a:t>Technologies Used</a:t>
-            </a:r>
-          </a:p>
-          <a:p>
-            <a:pPr>
-              <a:spcBef>
-                <a:spcPts val="50"/>
-              </a:spcBef>
-            </a:pPr>
-            <a:r>
-              <a:rPr sz="1200" b="1" dirty="0">
-                <a:solidFill>
-                  <a:srgbClr val="1E3A8A"/>
-                </a:solidFill>
-                <a:latin typeface="Times New Roman"/>
-              </a:rPr>
-              <a:t>• HTML5 &amp; WebGL 2.0 —</a:t>
-            </a:r>
-            <a:r>
-              <a:rPr sz="1200" dirty="0">
-                <a:solidFill>
-                  <a:srgbClr val="0F172A"/>
-                </a:solidFill>
-                <a:latin typeface="Times New Roman"/>
-              </a:rPr>
-              <a:t> Sub-16ms telemetry.</a:t>
-            </a:r>
-          </a:p>
-          <a:p>
-            <a:pPr>
-              <a:spcBef>
-                <a:spcPts val="50"/>
-              </a:spcBef>
-            </a:pPr>
-            <a:r>
-              <a:rPr sz="1200" b="1" dirty="0">
-                <a:solidFill>
-                  <a:srgbClr val="1E3A8A"/>
-                </a:solidFill>
-                <a:latin typeface="Times New Roman"/>
-              </a:rPr>
-              <a:t>• Python &amp; </a:t>
-            </a:r>
-            <a:r>
-              <a:rPr sz="1200" b="1" dirty="0" err="1">
-                <a:solidFill>
-                  <a:srgbClr val="1E3A8A"/>
-                </a:solidFill>
-                <a:latin typeface="Times New Roman"/>
-              </a:rPr>
-              <a:t>FastAPI</a:t>
-            </a:r>
-            <a:r>
-              <a:rPr sz="1200" b="1" dirty="0">
-                <a:solidFill>
-                  <a:srgbClr val="1E3A8A"/>
-                </a:solidFill>
-                <a:latin typeface="Times New Roman"/>
-              </a:rPr>
-              <a:t> —</a:t>
-            </a:r>
-            <a:r>
-              <a:rPr sz="1200" dirty="0">
-                <a:solidFill>
-                  <a:srgbClr val="0F172A"/>
-                </a:solidFill>
-                <a:latin typeface="Times New Roman"/>
-              </a:rPr>
-              <a:t> High-throughput streaming.</a:t>
-            </a:r>
-          </a:p>
-          <a:p>
-            <a:pPr>
-              <a:spcBef>
-                <a:spcPts val="50"/>
-              </a:spcBef>
-            </a:pPr>
-            <a:r>
-              <a:rPr sz="1200" b="1" dirty="0">
-                <a:solidFill>
-                  <a:srgbClr val="1E3A8A"/>
-                </a:solidFill>
-                <a:latin typeface="Times New Roman"/>
-              </a:rPr>
-              <a:t>• NumPy &amp; SciPy —</a:t>
-            </a:r>
-            <a:r>
-              <a:rPr sz="1200" dirty="0">
-                <a:solidFill>
-                  <a:srgbClr val="0F172A"/>
-                </a:solidFill>
-                <a:latin typeface="Times New Roman"/>
-              </a:rPr>
-              <a:t> Accelerated FFT &amp; PSD.</a:t>
-            </a:r>
-          </a:p>
-          <a:p>
-            <a:pPr>
-              <a:spcBef>
-                <a:spcPts val="50"/>
-              </a:spcBef>
-            </a:pPr>
-            <a:r>
-              <a:rPr sz="1200" b="1" dirty="0">
-                <a:solidFill>
-                  <a:srgbClr val="1E3A8A"/>
-                </a:solidFill>
-                <a:latin typeface="Times New Roman"/>
-              </a:rPr>
-              <a:t>• 1D-CNN + Bi-LSTM —</a:t>
-            </a:r>
-            <a:r>
-              <a:rPr sz="1200" dirty="0">
-                <a:solidFill>
-                  <a:srgbClr val="0F172A"/>
-                </a:solidFill>
-                <a:latin typeface="Times New Roman"/>
-              </a:rPr>
-              <a:t> Neural AMC classification.</a:t>
-            </a:r>
-          </a:p>
-          <a:p>
-            <a:pPr>
-              <a:spcBef>
-                <a:spcPts val="50"/>
-              </a:spcBef>
-            </a:pPr>
-            <a:r>
-              <a:rPr sz="1200" b="1" dirty="0">
-                <a:solidFill>
-                  <a:srgbClr val="1E3A8A"/>
-                </a:solidFill>
-                <a:latin typeface="Times New Roman"/>
-              </a:rPr>
-              <a:t>• GF(2) Matrix Solver —</a:t>
-            </a:r>
-            <a:r>
-              <a:rPr sz="1200" dirty="0">
-                <a:solidFill>
-                  <a:srgbClr val="0F172A"/>
-                </a:solidFill>
-                <a:latin typeface="Times New Roman"/>
-              </a:rPr>
-              <a:t> Fast rank solver.</a:t>
-            </a:r>
-          </a:p>
-          <a:p>
-            <a:pPr>
-              <a:spcBef>
-                <a:spcPts val="50"/>
-              </a:spcBef>
-            </a:pPr>
-            <a:r>
-              <a:rPr sz="1200" b="1" dirty="0">
-                <a:solidFill>
-                  <a:srgbClr val="1E3A8A"/>
-                </a:solidFill>
-                <a:latin typeface="Times New Roman"/>
-              </a:rPr>
-              <a:t>• Viterbi/Reed-Solomon —</a:t>
-            </a:r>
-            <a:r>
-              <a:rPr sz="1200" dirty="0">
-                <a:solidFill>
-                  <a:srgbClr val="0F172A"/>
-                </a:solidFill>
-                <a:latin typeface="Times New Roman"/>
-              </a:rPr>
-              <a:t> FEC channel decoders.</a:t>
-            </a:r>
-          </a:p>
-        </p:txBody>
-      </p:sp>
-      <p:sp>
-        <p:nvSpPr>
-          <p:cNvPr id="17418" name="Rounded Rectangle 17417"/>
+              <a:t>System Architecture</a:t>
+            </a:r>
+          </a:p>
+        </p:txBody>
+      </p:sp>
+      <p:pic>
+        <p:nvPicPr>
+          <p:cNvPr id="17413" name="Picture 17412" descr="spectra_multitier_architecture.png"/>
+          <p:cNvPicPr>
+            <a:picLocks noChangeAspect="1"/>
+          </p:cNvPicPr>
+          <p:nvPr/>
+        </p:nvPicPr>
+        <p:blipFill>
+          <a:blip r:embed="rId4"/>
+          <a:stretch>
+            <a:fillRect/>
+          </a:stretch>
+        </p:blipFill>
+        <p:spPr>
+          <a:xfrm>
+            <a:off x="365760" y="1280160"/>
+            <a:ext cx="11338560" cy="3429000"/>
+          </a:xfrm>
+          <a:prstGeom prst="rect">
+            <a:avLst/>
+          </a:prstGeom>
+        </p:spPr>
+      </p:pic>
+      <p:sp>
+        <p:nvSpPr>
+          <p:cNvPr id="17414" name="Rounded Rectangle 17413"/>
           <p:cNvSpPr/>
           <p:nvPr/>
         </p:nvSpPr>
         <p:spPr>
           <a:xfrm>
-            <a:off x="4007031" y="3837029"/>
-            <a:ext cx="3875098" cy="2276856"/>
+            <a:off x="365759" y="4983480"/>
+            <a:ext cx="3657600" cy="1737360"/>
           </a:xfrm>
           <a:prstGeom prst="roundRect">
             <a:avLst/>
           </a:prstGeom>
           <a:solidFill>
-            <a:srgbClr val="F8FAFC"/>
+            <a:srgbClr val="E2E8F0"/>
           </a:solidFill>
-          <a:ln w="19050">
-            <a:solidFill>
-              <a:srgbClr val="94A3B8"/>
-            </a:solidFill>
+          <a:ln>
+            <a:noFill/>
           </a:ln>
         </p:spPr>
         <p:style>
@@ -7509,19 +7347,63 @@
           <a:lstStyle/>
           <a:p>
             <a:pPr algn="ctr"/>
-            <a:endParaRPr/>
-          </a:p>
-        </p:txBody>
-      </p:sp>
-      <p:sp>
-        <p:nvSpPr>
-          <p:cNvPr id="17419" name="TextBox 17418"/>
+          </a:p>
+        </p:txBody>
+      </p:sp>
+      <p:sp>
+        <p:nvSpPr>
+          <p:cNvPr id="17415" name="Rounded Rectangle 17414"/>
+          <p:cNvSpPr/>
+          <p:nvPr/>
+        </p:nvSpPr>
+        <p:spPr>
+          <a:xfrm>
+            <a:off x="320040" y="4937760"/>
+            <a:ext cx="3657600" cy="1737360"/>
+          </a:xfrm>
+          <a:prstGeom prst="roundRect">
+            <a:avLst/>
+          </a:prstGeom>
+          <a:solidFill>
+            <a:srgbClr val="F8FAFC"/>
+          </a:solidFill>
+          <a:ln w="19050">
+            <a:solidFill>
+              <a:srgbClr val="94A3B8"/>
+            </a:solidFill>
+          </a:ln>
+        </p:spPr>
+        <p:style>
+          <a:lnRef idx="1">
+            <a:schemeClr val="accent1"/>
+          </a:lnRef>
+          <a:fillRef idx="3">
+            <a:schemeClr val="accent1"/>
+          </a:fillRef>
+          <a:effectRef idx="2">
+            <a:schemeClr val="accent1"/>
+          </a:effectRef>
+          <a:fontRef idx="minor">
+            <a:schemeClr val="lt1"/>
+          </a:fontRef>
+        </p:style>
+        <p:txBody>
+          <a:bodyPr rtlCol="0" anchor="ctr"/>
+          <a:lstStyle/>
+          <a:p>
+            <a:pPr algn="ctr"/>
+          </a:p>
+        </p:txBody>
+      </p:sp>
+      <p:sp>
+        <p:nvSpPr>
+          <p:cNvPr id="17416" name="TextBox 17415"/>
           <p:cNvSpPr txBox="1"/>
           <p:nvPr/>
         </p:nvSpPr>
         <p:spPr>
           <a:xfrm>
-            <a:off x="4205152" y="3940117"/>
+            <a:off x="457200" y="5029200"/>
             <a:ext cx="3383280" cy="1554480"/>
           </a:xfrm>
           <a:prstGeom prst="rect">
@@ -7530,13 +7412,285 @@
           <a:noFill/>
         </p:spPr>
         <p:txBody>
-          <a:bodyPr wrap="square" lIns="0" tIns="0" rIns="0" bIns="0">
+          <a:bodyPr wrap="square" lIns="0" rIns="0" tIns="0" bIns="0">
             <a:spAutoFit/>
           </a:bodyPr>
           <a:lstStyle/>
           <a:p>
             <a:r>
-              <a:rPr sz="1500" b="1" dirty="0">
+              <a:rPr sz="1500" b="1">
+                <a:solidFill>
+                  <a:srgbClr val="1E3A8A"/>
+                </a:solidFill>
+                <a:latin typeface="Times New Roman"/>
+              </a:rPr>
+              <a:t>Technologies Used</a:t>
+            </a:r>
+          </a:p>
+          <a:p>
+            <a:pPr>
+              <a:spcBef>
+                <a:spcPts val="50"/>
+              </a:spcBef>
+            </a:pPr>
+            <a:r>
+              <a:rPr sz="950" b="1">
+                <a:solidFill>
+                  <a:srgbClr val="1E3A8A"/>
+                </a:solidFill>
+                <a:latin typeface="Times New Roman"/>
+              </a:rPr>
+              <a:t>• HTML5 &amp; WebGL 2.0 —</a:t>
+            </a:r>
+            <a:r>
+              <a:rPr sz="950">
+                <a:solidFill>
+                  <a:srgbClr val="0F172A"/>
+                </a:solidFill>
+                <a:latin typeface="Times New Roman"/>
+              </a:rPr>
+              <a:t> Sub-16ms telemetry.</a:t>
+            </a:r>
+          </a:p>
+          <a:p>
+            <a:pPr>
+              <a:spcBef>
+                <a:spcPts val="50"/>
+              </a:spcBef>
+            </a:pPr>
+            <a:r>
+              <a:rPr sz="950" b="1">
+                <a:solidFill>
+                  <a:srgbClr val="1E3A8A"/>
+                </a:solidFill>
+                <a:latin typeface="Times New Roman"/>
+              </a:rPr>
+              <a:t>• Python &amp; FastAPI —</a:t>
+            </a:r>
+            <a:r>
+              <a:rPr sz="950">
+                <a:solidFill>
+                  <a:srgbClr val="0F172A"/>
+                </a:solidFill>
+                <a:latin typeface="Times New Roman"/>
+              </a:rPr>
+              <a:t> High-throughput streaming.</a:t>
+            </a:r>
+          </a:p>
+          <a:p>
+            <a:pPr>
+              <a:spcBef>
+                <a:spcPts val="50"/>
+              </a:spcBef>
+            </a:pPr>
+            <a:r>
+              <a:rPr sz="950" b="1">
+                <a:solidFill>
+                  <a:srgbClr val="1E3A8A"/>
+                </a:solidFill>
+                <a:latin typeface="Times New Roman"/>
+              </a:rPr>
+              <a:t>• NumPy &amp; SciPy —</a:t>
+            </a:r>
+            <a:r>
+              <a:rPr sz="950">
+                <a:solidFill>
+                  <a:srgbClr val="0F172A"/>
+                </a:solidFill>
+                <a:latin typeface="Times New Roman"/>
+              </a:rPr>
+              <a:t> Accelerated FFT &amp; PSD.</a:t>
+            </a:r>
+          </a:p>
+          <a:p>
+            <a:pPr>
+              <a:spcBef>
+                <a:spcPts val="50"/>
+              </a:spcBef>
+            </a:pPr>
+            <a:r>
+              <a:rPr sz="950" b="1">
+                <a:solidFill>
+                  <a:srgbClr val="1E3A8A"/>
+                </a:solidFill>
+                <a:latin typeface="Times New Roman"/>
+              </a:rPr>
+              <a:t>• 1D-CNN + Bi-LSTM —</a:t>
+            </a:r>
+            <a:r>
+              <a:rPr sz="950">
+                <a:solidFill>
+                  <a:srgbClr val="0F172A"/>
+                </a:solidFill>
+                <a:latin typeface="Times New Roman"/>
+              </a:rPr>
+              <a:t> Neural AMC classification.</a:t>
+            </a:r>
+          </a:p>
+          <a:p>
+            <a:pPr>
+              <a:spcBef>
+                <a:spcPts val="50"/>
+              </a:spcBef>
+            </a:pPr>
+            <a:r>
+              <a:rPr sz="950" b="1">
+                <a:solidFill>
+                  <a:srgbClr val="1E3A8A"/>
+                </a:solidFill>
+                <a:latin typeface="Times New Roman"/>
+              </a:rPr>
+              <a:t>• GF(2) Matrix Solver —</a:t>
+            </a:r>
+            <a:r>
+              <a:rPr sz="950">
+                <a:solidFill>
+                  <a:srgbClr val="0F172A"/>
+                </a:solidFill>
+                <a:latin typeface="Times New Roman"/>
+              </a:rPr>
+              <a:t> Fast rank solver.</a:t>
+            </a:r>
+          </a:p>
+          <a:p>
+            <a:pPr>
+              <a:spcBef>
+                <a:spcPts val="50"/>
+              </a:spcBef>
+            </a:pPr>
+            <a:r>
+              <a:rPr sz="950" b="1">
+                <a:solidFill>
+                  <a:srgbClr val="1E3A8A"/>
+                </a:solidFill>
+                <a:latin typeface="Times New Roman"/>
+              </a:rPr>
+              <a:t>• Viterbi/Reed-Solomon —</a:t>
+            </a:r>
+            <a:r>
+              <a:rPr sz="950">
+                <a:solidFill>
+                  <a:srgbClr val="0F172A"/>
+                </a:solidFill>
+                <a:latin typeface="Times New Roman"/>
+              </a:rPr>
+              <a:t> FEC channel decoders.</a:t>
+            </a:r>
+          </a:p>
+        </p:txBody>
+      </p:sp>
+      <p:sp>
+        <p:nvSpPr>
+          <p:cNvPr id="17417" name="Rounded Rectangle 17416"/>
+          <p:cNvSpPr/>
+          <p:nvPr/>
+        </p:nvSpPr>
+        <p:spPr>
+          <a:xfrm>
+            <a:off x="4251959" y="4983480"/>
+            <a:ext cx="3657600" cy="1737360"/>
+          </a:xfrm>
+          <a:prstGeom prst="roundRect">
+            <a:avLst/>
+          </a:prstGeom>
+          <a:solidFill>
+            <a:srgbClr val="E2E8F0"/>
+          </a:solidFill>
+          <a:ln>
+            <a:noFill/>
+          </a:ln>
+        </p:spPr>
+        <p:style>
+          <a:lnRef idx="1">
+            <a:schemeClr val="accent1"/>
+          </a:lnRef>
+          <a:fillRef idx="3">
+            <a:schemeClr val="accent1"/>
+          </a:fillRef>
+          <a:effectRef idx="2">
+            <a:schemeClr val="accent1"/>
+          </a:effectRef>
+          <a:fontRef idx="minor">
+            <a:schemeClr val="lt1"/>
+          </a:fontRef>
+        </p:style>
+        <p:txBody>
+          <a:bodyPr rtlCol="0" anchor="ctr"/>
+          <a:lstStyle/>
+          <a:p>
+            <a:pPr algn="ctr"/>
+          </a:p>
+        </p:txBody>
+      </p:sp>
+      <p:sp>
+        <p:nvSpPr>
+          <p:cNvPr id="17418" name="Rounded Rectangle 17417"/>
+          <p:cNvSpPr/>
+          <p:nvPr/>
+        </p:nvSpPr>
+        <p:spPr>
+          <a:xfrm>
+            <a:off x="4206240" y="4937760"/>
+            <a:ext cx="3657600" cy="1737360"/>
+          </a:xfrm>
+          <a:prstGeom prst="roundRect">
+            <a:avLst/>
+          </a:prstGeom>
+          <a:solidFill>
+            <a:srgbClr val="F8FAFC"/>
+          </a:solidFill>
+          <a:ln w="19050">
+            <a:solidFill>
+              <a:srgbClr val="94A3B8"/>
+            </a:solidFill>
+          </a:ln>
+        </p:spPr>
+        <p:style>
+          <a:lnRef idx="1">
+            <a:schemeClr val="accent1"/>
+          </a:lnRef>
+          <a:fillRef idx="3">
+            <a:schemeClr val="accent1"/>
+          </a:fillRef>
+          <a:effectRef idx="2">
+            <a:schemeClr val="accent1"/>
+          </a:effectRef>
+          <a:fontRef idx="minor">
+            <a:schemeClr val="lt1"/>
+          </a:fontRef>
+        </p:style>
+        <p:txBody>
+          <a:bodyPr rtlCol="0" anchor="ctr"/>
+          <a:lstStyle/>
+          <a:p>
+            <a:pPr algn="ctr"/>
+          </a:p>
+        </p:txBody>
+      </p:sp>
+      <p:sp>
+        <p:nvSpPr>
+          <p:cNvPr id="17419" name="TextBox 17418"/>
+          <p:cNvSpPr txBox="1"/>
+          <p:nvPr/>
+        </p:nvSpPr>
+        <p:spPr>
+          <a:xfrm>
+            <a:off x="4343400" y="5029200"/>
+            <a:ext cx="3383280" cy="1554480"/>
+          </a:xfrm>
+          <a:prstGeom prst="rect">
+            <a:avLst/>
+          </a:prstGeom>
+          <a:noFill/>
+        </p:spPr>
+        <p:txBody>
+          <a:bodyPr wrap="square" lIns="0" rIns="0" tIns="0" bIns="0">
+            <a:spAutoFit/>
+          </a:bodyPr>
+          <a:lstStyle/>
+          <a:p>
+            <a:r>
+              <a:rPr sz="1500" b="1">
                 <a:solidFill>
                   <a:srgbClr val="1E3A8A"/>
                 </a:solidFill>
@@ -7552,31 +7706,13 @@
               </a:spcBef>
             </a:pPr>
             <a:r>
-              <a:rPr sz="950" dirty="0">
+              <a:rPr sz="950">
                 <a:solidFill>
                   <a:srgbClr val="0F172A"/>
                 </a:solidFill>
                 <a:latin typeface="Times New Roman"/>
               </a:rPr>
-              <a:t>Real-Time Tactical Spectrum &amp; Telemetry GUI (</a:t>
-            </a:r>
-            <a:r>
-              <a:rPr sz="950" dirty="0" err="1">
-                <a:solidFill>
-                  <a:srgbClr val="0F172A"/>
-                </a:solidFill>
-                <a:latin typeface="Times New Roman"/>
-              </a:rPr>
-              <a:t>FastAPI</a:t>
-            </a:r>
-            <a:r>
-              <a:rPr sz="950" dirty="0">
-                <a:solidFill>
-                  <a:srgbClr val="0F172A"/>
-                </a:solidFill>
-                <a:latin typeface="Times New Roman"/>
-              </a:rPr>
-              <a:t> + WebGL)</a:t>
+              <a:t>Real-Time Tactical Spectrum &amp; Telemetry GUI (FastAPI + WebGL)</a:t>
             </a:r>
           </a:p>
         </p:txBody>
@@ -7597,8 +7733,8 @@
         </p:blipFill>
         <p:spPr>
           <a:xfrm>
-            <a:off x="3935840" y="4169664"/>
-            <a:ext cx="3946288" cy="2130234"/>
+            <a:off x="4297680" y="5303520"/>
+            <a:ext cx="3474720" cy="1280160"/>
           </a:xfrm>
           <a:prstGeom prst="rect">
             <a:avLst/>
@@ -7607,25 +7743,23 @@
       </p:pic>
       <p:sp>
         <p:nvSpPr>
-          <p:cNvPr id="17422" name="Rounded Rectangle 17421"/>
+          <p:cNvPr id="17421" name="Rounded Rectangle 17420"/>
           <p:cNvSpPr/>
           <p:nvPr/>
         </p:nvSpPr>
         <p:spPr>
           <a:xfrm>
-            <a:off x="8321040" y="4334416"/>
+            <a:off x="8138160" y="4983480"/>
             <a:ext cx="3657600" cy="1737360"/>
           </a:xfrm>
           <a:prstGeom prst="roundRect">
             <a:avLst/>
           </a:prstGeom>
           <a:solidFill>
-            <a:srgbClr val="F8FAFC"/>
+            <a:srgbClr val="E2E8F0"/>
           </a:solidFill>
-          <a:ln w="19050">
-            <a:solidFill>
-              <a:srgbClr val="94A3B8"/>
-            </a:solidFill>
+          <a:ln>
+            <a:noFill/>
           </a:ln>
         </p:spPr>
         <p:style>
@@ -7647,7 +7781,51 @@
           <a:lstStyle/>
           <a:p>
             <a:pPr algn="ctr"/>
-            <a:endParaRPr/>
+          </a:p>
+        </p:txBody>
+      </p:sp>
+      <p:sp>
+        <p:nvSpPr>
+          <p:cNvPr id="17422" name="Rounded Rectangle 17421"/>
+          <p:cNvSpPr/>
+          <p:nvPr/>
+        </p:nvSpPr>
+        <p:spPr>
+          <a:xfrm>
+            <a:off x="8092440" y="4937760"/>
+            <a:ext cx="3657600" cy="1737360"/>
+          </a:xfrm>
+          <a:prstGeom prst="roundRect">
+            <a:avLst/>
+          </a:prstGeom>
+          <a:solidFill>
+            <a:srgbClr val="F8FAFC"/>
+          </a:solidFill>
+          <a:ln w="19050">
+            <a:solidFill>
+              <a:srgbClr val="94A3B8"/>
+            </a:solidFill>
+          </a:ln>
+        </p:spPr>
+        <p:style>
+          <a:lnRef idx="1">
+            <a:schemeClr val="accent1"/>
+          </a:lnRef>
+          <a:fillRef idx="3">
+            <a:schemeClr val="accent1"/>
+          </a:fillRef>
+          <a:effectRef idx="2">
+            <a:schemeClr val="accent1"/>
+          </a:effectRef>
+          <a:fontRef idx="minor">
+            <a:schemeClr val="lt1"/>
+          </a:fontRef>
+        </p:style>
+        <p:txBody>
+          <a:bodyPr rtlCol="0" anchor="ctr"/>
+          <a:lstStyle/>
+          <a:p>
+            <a:pPr algn="ctr"/>
           </a:p>
         </p:txBody>
       </p:sp>
@@ -7659,8 +7837,8 @@
         </p:nvSpPr>
         <p:spPr>
           <a:xfrm>
-            <a:off x="8458200" y="4532699"/>
-            <a:ext cx="3383280" cy="1184940"/>
+            <a:off x="8229600" y="5029200"/>
+            <a:ext cx="3383280" cy="1554480"/>
           </a:xfrm>
           <a:prstGeom prst="rect">
             <a:avLst/>
@@ -7668,13 +7846,13 @@
           <a:noFill/>
         </p:spPr>
         <p:txBody>
-          <a:bodyPr wrap="square" lIns="0" tIns="0" rIns="0" bIns="0">
+          <a:bodyPr wrap="square" lIns="0" rIns="0" tIns="0" bIns="0">
             <a:spAutoFit/>
           </a:bodyPr>
           <a:lstStyle/>
           <a:p>
             <a:r>
-              <a:rPr sz="1600" b="1" dirty="0">
+              <a:rPr sz="1500" b="1">
                 <a:solidFill>
                   <a:srgbClr val="1E3A8A"/>
                 </a:solidFill>
@@ -7690,7 +7868,7 @@
               </a:spcBef>
             </a:pPr>
             <a:r>
-              <a:rPr sz="1400" b="1" dirty="0">
+              <a:rPr sz="950" b="1">
                 <a:solidFill>
                   <a:srgbClr val="1E3A8A"/>
                 </a:solidFill>
@@ -7699,13 +7877,13 @@
               <a:t>• GitHub: </a:t>
             </a:r>
             <a:r>
-              <a:rPr sz="1400" dirty="0">
+              <a:rPr sz="950">
                 <a:solidFill>
                   <a:srgbClr val="0F172A"/>
                 </a:solidFill>
                 <a:latin typeface="Times New Roman"/>
               </a:rPr>
-              <a:t>Futuristics-NTRO </a:t>
+              <a:t>github.com/harikesh2709-creator/FUTURISTICS </a:t>
             </a:r>
           </a:p>
           <a:p>
@@ -7715,40 +7893,33 @@
               </a:spcBef>
             </a:pPr>
             <a:r>
-              <a:rPr sz="1400" b="1" dirty="0">
+              <a:rPr sz="950" b="1">
                 <a:solidFill>
                   <a:srgbClr val="1E3A8A"/>
                 </a:solidFill>
                 <a:latin typeface="Times New Roman"/>
               </a:rPr>
-              <a:t>• Video: </a:t>
-            </a:r>
-            <a:r>
-              <a:rPr sz="1400" dirty="0">
+              <a:t>• YouTube: </a:t>
+            </a:r>
+            <a:r>
+              <a:rPr sz="950">
                 <a:solidFill>
                   <a:srgbClr val="0F172A"/>
                 </a:solidFill>
                 <a:latin typeface="Times New Roman"/>
               </a:rPr>
-              <a:t>youtu.be/spectra-</a:t>
-            </a:r>
-            <a:r>
-              <a:rPr sz="1400" dirty="0" err="1">
-                <a:solidFill>
-                  <a:srgbClr val="0F172A"/>
-                </a:solidFill>
-                <a:latin typeface="Times New Roman"/>
-              </a:rPr>
-              <a:t>ntro</a:t>
-            </a:r>
-            <a:r>
-              <a:rPr sz="1400" dirty="0">
-                <a:solidFill>
-                  <a:srgbClr val="0F172A"/>
-                </a:solidFill>
-                <a:latin typeface="Times New Roman"/>
-              </a:rPr>
-              <a:t> </a:t>
+              <a:t>youtu.be/FUTURISTICS-SPECTRA </a:t>
+            </a:r>
+          </a:p>
+          <a:p>
+            <a:r>
+              <a:rPr sz="850">
+                <a:solidFill>
+                  <a:srgbClr val="475569"/>
+                </a:solidFill>
+                <a:latin typeface="Times New Roman"/>
+              </a:rPr>
+              <a:t>  (5-Min Demo Walkthrough)</a:t>
             </a:r>
           </a:p>
           <a:p>
@@ -7758,7 +7929,7 @@
               </a:spcBef>
             </a:pPr>
             <a:r>
-              <a:rPr sz="1400" b="1" dirty="0">
+              <a:rPr sz="950" b="1">
                 <a:solidFill>
                   <a:srgbClr val="1E3A8A"/>
                 </a:solidFill>
@@ -7767,58 +7938,25 @@
               <a:t>• Status: </a:t>
             </a:r>
             <a:r>
-              <a:rPr sz="1400" dirty="0">
+              <a:rPr sz="950">
                 <a:solidFill>
                   <a:srgbClr val="0F172A"/>
                 </a:solidFill>
                 <a:latin typeface="Times New Roman"/>
               </a:rPr>
-              <a:t>4</a:t>
-            </a:r>
-            <a:r>
-              <a:rPr lang="en-GB" sz="1400" dirty="0">
-                <a:solidFill>
-                  <a:srgbClr val="0F172A"/>
-                </a:solidFill>
-                <a:latin typeface="Times New Roman"/>
-              </a:rPr>
-              <a:t>0</a:t>
-            </a:r>
-            <a:r>
-              <a:rPr sz="1400" dirty="0">
-                <a:solidFill>
-                  <a:srgbClr val="0F172A"/>
-                </a:solidFill>
-                <a:latin typeface="Times New Roman"/>
-              </a:rPr>
-              <a:t>% completed. </a:t>
-            </a:r>
-          </a:p>
-          <a:p>
-            <a:r>
-              <a:rPr sz="1400" dirty="0">
+              <a:t>Phase-1 Functional Prototype </a:t>
+            </a:r>
+          </a:p>
+          <a:p>
+            <a:r>
+              <a:rPr sz="850">
                 <a:solidFill>
                   <a:srgbClr val="475569"/>
                 </a:solidFill>
                 <a:latin typeface="Times New Roman"/>
               </a:rPr>
-              <a:t>  Core ingestion &amp; UI opera</a:t>
-            </a:r>
-            <a:r>
-              <a:rPr lang="en-IN" sz="1400" dirty="0" err="1">
-                <a:solidFill>
-                  <a:srgbClr val="475569"/>
-                </a:solidFill>
-                <a:latin typeface="Times New Roman"/>
-              </a:rPr>
-              <a:t>tional</a:t>
-            </a:r>
-            <a:endParaRPr sz="1400" dirty="0">
-              <a:solidFill>
-                <a:srgbClr val="475569"/>
-              </a:solidFill>
-              <a:latin typeface="Times New Roman"/>
-            </a:endParaRPr>
+              <a:t>  (Air-gapped DSP + Neural AMC)</a:t>
+            </a:r>
           </a:p>
         </p:txBody>
       </p:sp>
@@ -7946,7 +8084,7 @@
           <a:bodyPr/>
           <a:lstStyle/>
           <a:p>
-            <a:pPr algn="ctr" eaLnBrk="1" hangingPunct="1"/>
+            <a:pPr eaLnBrk="1" hangingPunct="1" algn="ctr"/>
             <a:r>
               <a:rPr sz="2400" b="1">
                 <a:solidFill>
@@ -8093,7 +8231,7 @@
                 <a16:creationId xmlns:a16="http://schemas.microsoft.com/office/drawing/2014/main" id="{5DBCE864-823D-4A13-9607-5DA1F0ED5FB8}"/>
               </a:ext>
               <a:ext uri="{C183D7F6-B498-43B3-948B-1728B52AA6E4}">
-                <adec:decorative xmlns:adec="http://schemas.microsoft.com/office/drawing/2017/decorative" val="0"/>
+                <adec:decorative xmlns:adec="http://schemas.microsoft.com/office/drawing/2017/decorative" xmlns="" val="0"/>
               </a:ext>
             </a:extLst>
           </p:cNvPr>
@@ -8132,7 +8270,7 @@
           </a:fontRef>
         </p:style>
         <p:txBody>
-          <a:bodyPr wrap="none" lIns="0" tIns="0" rIns="0" bIns="0" rtlCol="0" anchor="ctr"/>
+          <a:bodyPr rtlCol="0" anchor="ctr" wrap="none" lIns="0" rIns="0" tIns="0" bIns="0"/>
           <a:lstStyle/>
           <a:p>
             <a:pPr algn="ctr"/>
@@ -8219,7 +8357,6 @@
           <a:lstStyle/>
           <a:p>
             <a:pPr algn="ctr"/>
-            <a:endParaRPr/>
           </a:p>
         </p:txBody>
       </p:sp>
@@ -8265,7 +8402,6 @@
           <a:lstStyle/>
           <a:p>
             <a:pPr algn="ctr"/>
-            <a:endParaRPr/>
           </a:p>
         </p:txBody>
       </p:sp>
@@ -8286,7 +8422,7 @@
           <a:noFill/>
         </p:spPr>
         <p:txBody>
-          <a:bodyPr wrap="square" lIns="0" tIns="0" rIns="0" bIns="0">
+          <a:bodyPr wrap="square" lIns="0" rIns="0" tIns="0" bIns="0">
             <a:spAutoFit/>
           </a:bodyPr>
           <a:lstStyle/>
@@ -8407,7 +8543,6 @@
           <a:lstStyle/>
           <a:p>
             <a:pPr algn="ctr"/>
-            <a:endParaRPr/>
           </a:p>
         </p:txBody>
       </p:sp>
@@ -8453,7 +8588,6 @@
           <a:lstStyle/>
           <a:p>
             <a:pPr algn="ctr"/>
-            <a:endParaRPr/>
           </a:p>
         </p:txBody>
       </p:sp>
@@ -8474,7 +8608,7 @@
           <a:noFill/>
         </p:spPr>
         <p:txBody>
-          <a:bodyPr wrap="square" lIns="0" tIns="0" rIns="0" bIns="0">
+          <a:bodyPr wrap="square" lIns="0" rIns="0" tIns="0" bIns="0">
             <a:spAutoFit/>
           </a:bodyPr>
           <a:lstStyle/>
@@ -8595,7 +8729,6 @@
           <a:lstStyle/>
           <a:p>
             <a:pPr algn="ctr"/>
-            <a:endParaRPr/>
           </a:p>
         </p:txBody>
       </p:sp>
@@ -8641,7 +8774,6 @@
           <a:lstStyle/>
           <a:p>
             <a:pPr algn="ctr"/>
-            <a:endParaRPr/>
           </a:p>
         </p:txBody>
       </p:sp>
@@ -8662,7 +8794,7 @@
           <a:noFill/>
         </p:spPr>
         <p:txBody>
-          <a:bodyPr wrap="square" lIns="0" tIns="0" rIns="0" bIns="0">
+          <a:bodyPr wrap="square" lIns="0" rIns="0" tIns="0" bIns="0">
             <a:spAutoFit/>
           </a:bodyPr>
           <a:lstStyle/>
@@ -8783,7 +8915,6 @@
           <a:lstStyle/>
           <a:p>
             <a:pPr algn="ctr"/>
-            <a:endParaRPr/>
           </a:p>
         </p:txBody>
       </p:sp>
@@ -8829,7 +8960,6 @@
           <a:lstStyle/>
           <a:p>
             <a:pPr algn="ctr"/>
-            <a:endParaRPr/>
           </a:p>
         </p:txBody>
       </p:sp>
@@ -8850,7 +8980,7 @@
           <a:noFill/>
         </p:spPr>
         <p:txBody>
-          <a:bodyPr wrap="square" lIns="0" tIns="0" rIns="0" bIns="0">
+          <a:bodyPr wrap="square" lIns="0" rIns="0" tIns="0" bIns="0">
             <a:spAutoFit/>
           </a:bodyPr>
           <a:lstStyle/>
@@ -9060,7 +9190,7 @@
           <a:bodyPr/>
           <a:lstStyle/>
           <a:p>
-            <a:pPr algn="ctr" eaLnBrk="1" hangingPunct="1"/>
+            <a:pPr eaLnBrk="1" hangingPunct="1" algn="ctr"/>
             <a:r>
               <a:rPr sz="2400" b="1">
                 <a:solidFill>
@@ -9207,7 +9337,7 @@
                 <a16:creationId xmlns:a16="http://schemas.microsoft.com/office/drawing/2014/main" id="{5DBCE864-823D-4A13-9607-5DA1F0ED5FB8}"/>
               </a:ext>
               <a:ext uri="{C183D7F6-B498-43B3-948B-1728B52AA6E4}">
-                <adec:decorative xmlns:adec="http://schemas.microsoft.com/office/drawing/2017/decorative" val="0"/>
+                <adec:decorative xmlns:adec="http://schemas.microsoft.com/office/drawing/2017/decorative" xmlns="" val="0"/>
               </a:ext>
             </a:extLst>
           </p:cNvPr>
@@ -9246,7 +9376,7 @@
           </a:fontRef>
         </p:style>
         <p:txBody>
-          <a:bodyPr wrap="none" lIns="0" tIns="0" rIns="0" bIns="0" rtlCol="0" anchor="ctr"/>
+          <a:bodyPr rtlCol="0" anchor="ctr" wrap="none" lIns="0" rIns="0" tIns="0" bIns="0"/>
           <a:lstStyle/>
           <a:p>
             <a:pPr algn="ctr"/>
@@ -9333,7 +9463,6 @@
           <a:lstStyle/>
           <a:p>
             <a:pPr algn="ctr"/>
-            <a:endParaRPr/>
           </a:p>
         </p:txBody>
       </p:sp>
@@ -9379,7 +9508,6 @@
           <a:lstStyle/>
           <a:p>
             <a:pPr algn="ctr"/>
-            <a:endParaRPr/>
           </a:p>
         </p:txBody>
       </p:sp>
@@ -9614,7 +9742,6 @@
           <a:lstStyle/>
           <a:p>
             <a:pPr algn="ctr"/>
-            <a:endParaRPr/>
           </a:p>
         </p:txBody>
       </p:sp>
@@ -9660,7 +9787,6 @@
           <a:lstStyle/>
           <a:p>
             <a:pPr algn="ctr"/>
-            <a:endParaRPr/>
           </a:p>
         </p:txBody>
       </p:sp>
@@ -9673,7 +9799,7 @@
         <p:spPr>
           <a:xfrm>
             <a:off x="731520" y="1325880"/>
-            <a:ext cx="3931920" cy="2054409"/>
+            <a:ext cx="3931920" cy="2148839"/>
           </a:xfrm>
           <a:prstGeom prst="rect">
             <a:avLst/>
@@ -9681,13 +9807,13 @@
           <a:noFill/>
         </p:spPr>
         <p:txBody>
-          <a:bodyPr wrap="square" lIns="0" tIns="0" rIns="0" bIns="0">
+          <a:bodyPr wrap="square" lIns="0" rIns="0" tIns="0" bIns="0">
             <a:spAutoFit/>
           </a:bodyPr>
           <a:lstStyle/>
           <a:p>
             <a:r>
-              <a:rPr sz="1400" b="1">
+              <a:rPr sz="1500" b="1">
                 <a:solidFill>
                   <a:srgbClr val="1E3A8A"/>
                 </a:solidFill>
@@ -9703,7 +9829,7 @@
               </a:spcBef>
             </a:pPr>
             <a:r>
-              <a:rPr sz="1400" b="1">
+              <a:rPr sz="1050" b="1">
                 <a:solidFill>
                   <a:srgbClr val="1E3A8A"/>
                 </a:solidFill>
@@ -9712,7 +9838,7 @@
               <a:t>• Primary Core: </a:t>
             </a:r>
             <a:r>
-              <a:rPr sz="1400">
+              <a:rPr sz="1050">
                 <a:solidFill>
                   <a:srgbClr val="0F172A"/>
                 </a:solidFill>
@@ -9728,7 +9854,7 @@
               </a:spcBef>
             </a:pPr>
             <a:r>
-              <a:rPr sz="1400" b="1">
+              <a:rPr sz="1050" b="1">
                 <a:solidFill>
                   <a:srgbClr val="1E3A8A"/>
                 </a:solidFill>
@@ -9737,7 +9863,7 @@
               <a:t>• Tactical Forces: </a:t>
             </a:r>
             <a:r>
-              <a:rPr sz="1400">
+              <a:rPr sz="1050">
                 <a:solidFill>
                   <a:srgbClr val="0F172A"/>
                 </a:solidFill>
@@ -9753,7 +9879,7 @@
               </a:spcBef>
             </a:pPr>
             <a:r>
-              <a:rPr sz="1400" b="1">
+              <a:rPr sz="1050" b="1">
                 <a:solidFill>
                   <a:srgbClr val="1E3A8A"/>
                 </a:solidFill>
@@ -9762,7 +9888,7 @@
               <a:t>• Strategic Agencies: </a:t>
             </a:r>
             <a:r>
-              <a:rPr sz="1400">
+              <a:rPr sz="1050">
                 <a:solidFill>
                   <a:srgbClr val="0F172A"/>
                 </a:solidFill>
@@ -9813,7 +9939,6 @@
           <a:lstStyle/>
           <a:p>
             <a:pPr algn="ctr"/>
-            <a:endParaRPr/>
           </a:p>
         </p:txBody>
       </p:sp>
@@ -9859,7 +9984,6 @@
           <a:lstStyle/>
           <a:p>
             <a:pPr algn="ctr"/>
-            <a:endParaRPr/>
           </a:p>
         </p:txBody>
       </p:sp>
@@ -9872,7 +9996,7 @@
         <p:spPr>
           <a:xfrm>
             <a:off x="7525512" y="1325880"/>
-            <a:ext cx="3931920" cy="1777410"/>
+            <a:ext cx="3931920" cy="2148839"/>
           </a:xfrm>
           <a:prstGeom prst="rect">
             <a:avLst/>
@@ -9880,13 +10004,13 @@
           <a:noFill/>
         </p:spPr>
         <p:txBody>
-          <a:bodyPr wrap="square" lIns="0" tIns="0" rIns="0" bIns="0">
+          <a:bodyPr wrap="square" lIns="0" rIns="0" tIns="0" bIns="0">
             <a:spAutoFit/>
           </a:bodyPr>
           <a:lstStyle/>
           <a:p>
             <a:r>
-              <a:rPr sz="1200" b="1">
+              <a:rPr sz="1500" b="1">
                 <a:solidFill>
                   <a:srgbClr val="1E3A8A"/>
                 </a:solidFill>
@@ -9902,7 +10026,7 @@
               </a:spcBef>
             </a:pPr>
             <a:r>
-              <a:rPr sz="1200" b="1">
+              <a:rPr sz="1050" b="1">
                 <a:solidFill>
                   <a:srgbClr val="1E3A8A"/>
                 </a:solidFill>
@@ -9911,7 +10035,7 @@
               <a:t>• Total Autonomy: </a:t>
             </a:r>
             <a:r>
-              <a:rPr sz="1200">
+              <a:rPr sz="1050">
                 <a:solidFill>
                   <a:srgbClr val="0F172A"/>
                 </a:solidFill>
@@ -9927,7 +10051,7 @@
               </a:spcBef>
             </a:pPr>
             <a:r>
-              <a:rPr sz="1200" b="1">
+              <a:rPr sz="1050" b="1">
                 <a:solidFill>
                   <a:srgbClr val="1E3A8A"/>
                 </a:solidFill>
@@ -9936,7 +10060,7 @@
               <a:t>• Zero-Day Triage: </a:t>
             </a:r>
             <a:r>
-              <a:rPr sz="1200">
+              <a:rPr sz="1050">
                 <a:solidFill>
                   <a:srgbClr val="0F172A"/>
                 </a:solidFill>
@@ -9952,7 +10076,7 @@
               </a:spcBef>
             </a:pPr>
             <a:r>
-              <a:rPr sz="1200" b="1">
+              <a:rPr sz="1050" b="1">
                 <a:solidFill>
                   <a:srgbClr val="1E3A8A"/>
                 </a:solidFill>
@@ -9961,7 +10085,7 @@
               <a:t>• Economic Dominance: </a:t>
             </a:r>
             <a:r>
-              <a:rPr sz="1200">
+              <a:rPr sz="1050">
                 <a:solidFill>
                   <a:srgbClr val="0F172A"/>
                 </a:solidFill>
@@ -10012,7 +10136,6 @@
           <a:lstStyle/>
           <a:p>
             <a:pPr algn="ctr"/>
-            <a:endParaRPr/>
           </a:p>
         </p:txBody>
       </p:sp>
@@ -10058,7 +10181,6 @@
           <a:lstStyle/>
           <a:p>
             <a:pPr algn="ctr"/>
-            <a:endParaRPr/>
           </a:p>
         </p:txBody>
       </p:sp>
@@ -10071,7 +10193,7 @@
         <p:spPr>
           <a:xfrm>
             <a:off x="731520" y="3840479"/>
-            <a:ext cx="3931920" cy="1962076"/>
+            <a:ext cx="3931920" cy="2148839"/>
           </a:xfrm>
           <a:prstGeom prst="rect">
             <a:avLst/>
@@ -10079,13 +10201,13 @@
           <a:noFill/>
         </p:spPr>
         <p:txBody>
-          <a:bodyPr wrap="square" lIns="0" tIns="0" rIns="0" bIns="0">
+          <a:bodyPr wrap="square" lIns="0" rIns="0" tIns="0" bIns="0">
             <a:spAutoFit/>
           </a:bodyPr>
           <a:lstStyle/>
           <a:p>
             <a:r>
-              <a:rPr sz="1200" b="1">
+              <a:rPr sz="1500" b="1">
                 <a:solidFill>
                   <a:srgbClr val="1E3A8A"/>
                 </a:solidFill>
@@ -10101,7 +10223,7 @@
               </a:spcBef>
             </a:pPr>
             <a:r>
-              <a:rPr sz="1200" b="1">
+              <a:rPr sz="1050" b="1">
                 <a:solidFill>
                   <a:srgbClr val="1E3A8A"/>
                 </a:solidFill>
@@ -10110,7 +10232,7 @@
               <a:t>• 100x Efficiency Surge: </a:t>
             </a:r>
             <a:r>
-              <a:rPr sz="1200">
+              <a:rPr sz="1050">
                 <a:solidFill>
                   <a:srgbClr val="0F172A"/>
                 </a:solidFill>
@@ -10126,7 +10248,7 @@
               </a:spcBef>
             </a:pPr>
             <a:r>
-              <a:rPr sz="1200" b="1">
+              <a:rPr sz="1050" b="1">
                 <a:solidFill>
                   <a:srgbClr val="1E3A8A"/>
                 </a:solidFill>
@@ -10135,7 +10257,7 @@
               <a:t>• Cognitive Relief: </a:t>
             </a:r>
             <a:r>
-              <a:rPr sz="1200">
+              <a:rPr sz="1050">
                 <a:solidFill>
                   <a:srgbClr val="0F172A"/>
                 </a:solidFill>
@@ -10151,7 +10273,7 @@
               </a:spcBef>
             </a:pPr>
             <a:r>
-              <a:rPr sz="1200" b="1">
+              <a:rPr sz="1050" b="1">
                 <a:solidFill>
                   <a:srgbClr val="1E3A8A"/>
                 </a:solidFill>
@@ -10160,7 +10282,7 @@
               <a:t>• Forensic Ledger: </a:t>
             </a:r>
             <a:r>
-              <a:rPr sz="1200">
+              <a:rPr sz="1050">
                 <a:solidFill>
                   <a:srgbClr val="0F172A"/>
                 </a:solidFill>
@@ -10211,7 +10333,6 @@
           <a:lstStyle/>
           <a:p>
             <a:pPr algn="ctr"/>
-            <a:endParaRPr/>
           </a:p>
         </p:txBody>
       </p:sp>
@@ -10257,7 +10378,6 @@
           <a:lstStyle/>
           <a:p>
             <a:pPr algn="ctr"/>
-            <a:endParaRPr/>
           </a:p>
         </p:txBody>
       </p:sp>
@@ -10278,7 +10398,7 @@
           <a:noFill/>
         </p:spPr>
         <p:txBody>
-          <a:bodyPr wrap="square" lIns="0" tIns="0" rIns="0" bIns="0">
+          <a:bodyPr wrap="square" lIns="0" rIns="0" tIns="0" bIns="0">
             <a:spAutoFit/>
           </a:bodyPr>
           <a:lstStyle/>
@@ -10499,7 +10619,7 @@
           <a:bodyPr/>
           <a:lstStyle/>
           <a:p>
-            <a:pPr algn="ctr" eaLnBrk="1" hangingPunct="1"/>
+            <a:pPr eaLnBrk="1" hangingPunct="1" algn="ctr"/>
             <a:r>
               <a:rPr sz="2400" b="1">
                 <a:solidFill>
@@ -10646,7 +10766,7 @@
                 <a16:creationId xmlns:a16="http://schemas.microsoft.com/office/drawing/2014/main" id="{5DBCE864-823D-4A13-9607-5DA1F0ED5FB8}"/>
               </a:ext>
               <a:ext uri="{C183D7F6-B498-43B3-948B-1728B52AA6E4}">
-                <adec:decorative xmlns:adec="http://schemas.microsoft.com/office/drawing/2017/decorative" val="0"/>
+                <adec:decorative xmlns:adec="http://schemas.microsoft.com/office/drawing/2017/decorative" xmlns="" val="0"/>
               </a:ext>
             </a:extLst>
           </p:cNvPr>
@@ -10685,7 +10805,7 @@
           </a:fontRef>
         </p:style>
         <p:txBody>
-          <a:bodyPr wrap="none" lIns="0" tIns="0" rIns="0" bIns="0" rtlCol="0" anchor="ctr"/>
+          <a:bodyPr rtlCol="0" anchor="ctr" wrap="none" lIns="0" rIns="0" tIns="0" bIns="0"/>
           <a:lstStyle/>
           <a:p>
             <a:pPr algn="ctr"/>
@@ -10772,7 +10892,6 @@
           <a:lstStyle/>
           <a:p>
             <a:pPr algn="ctr"/>
-            <a:endParaRPr/>
           </a:p>
         </p:txBody>
       </p:sp>
@@ -10818,7 +10937,6 @@
           <a:lstStyle/>
           <a:p>
             <a:pPr algn="ctr"/>
-            <a:endParaRPr/>
           </a:p>
         </p:txBody>
       </p:sp>
@@ -10831,7 +10949,7 @@
         <p:spPr>
           <a:xfrm>
             <a:off x="868680" y="1371600"/>
-            <a:ext cx="10451592" cy="3949799"/>
+            <a:ext cx="10451592" cy="4526280"/>
           </a:xfrm>
           <a:prstGeom prst="rect">
             <a:avLst/>
@@ -10839,7 +10957,7 @@
           <a:noFill/>
         </p:spPr>
         <p:txBody>
-          <a:bodyPr wrap="square" lIns="0" tIns="0" rIns="0" bIns="0">
+          <a:bodyPr wrap="square" lIns="0" rIns="0" tIns="0" bIns="0">
             <a:spAutoFit/>
           </a:bodyPr>
           <a:lstStyle/>
@@ -10853,7 +10971,7 @@
               </a:spcAft>
             </a:pPr>
             <a:r>
-              <a:rPr sz="1400" b="1" dirty="0">
+              <a:rPr sz="1220" b="1">
                 <a:solidFill>
                   <a:srgbClr val="1E3A8A"/>
                 </a:solidFill>
@@ -10862,34 +10980,16 @@
               <a:t>• </a:t>
             </a:r>
             <a:r>
-              <a:rPr sz="1400" b="1" dirty="0">
+              <a:rPr sz="1220" b="1">
                 <a:solidFill>
                   <a:srgbClr val="0F172A"/>
                 </a:solidFill>
                 <a:latin typeface="Times New Roman"/>
               </a:rPr>
-              <a:t>[1] J. </a:t>
-            </a:r>
-            <a:r>
-              <a:rPr sz="1400" b="1" dirty="0" err="1">
-                <a:solidFill>
-                  <a:srgbClr val="0F172A"/>
-                </a:solidFill>
-                <a:latin typeface="Times New Roman"/>
-              </a:rPr>
-              <a:t>Proakis</a:t>
-            </a:r>
-            <a:r>
-              <a:rPr sz="1400" b="1" dirty="0">
-                <a:solidFill>
-                  <a:srgbClr val="0F172A"/>
-                </a:solidFill>
-                <a:latin typeface="Times New Roman"/>
-              </a:rPr>
-              <a:t> and M. Salehi, </a:t>
-            </a:r>
-            <a:r>
-              <a:rPr sz="1400" dirty="0">
+              <a:t>[1] J. Proakis and M. Salehi, </a:t>
+            </a:r>
+            <a:r>
+              <a:rPr sz="1220">
                 <a:solidFill>
                   <a:srgbClr val="2563EB"/>
                 </a:solidFill>
@@ -10898,7 +10998,7 @@
               <a:t>“Digital Communications (5th Edition),” McGraw-Hill Higher Education, 2018. DOI: 10.1036/0072957166. </a:t>
             </a:r>
             <a:r>
-              <a:rPr sz="1400" dirty="0">
+              <a:rPr sz="1080">
                 <a:solidFill>
                   <a:srgbClr val="475569"/>
                 </a:solidFill>
@@ -10917,7 +11017,7 @@
               </a:spcAft>
             </a:pPr>
             <a:r>
-              <a:rPr sz="1400" b="1" dirty="0">
+              <a:rPr sz="1220" b="1">
                 <a:solidFill>
                   <a:srgbClr val="1E3A8A"/>
                 </a:solidFill>
@@ -10926,34 +11026,16 @@
               <a:t>• </a:t>
             </a:r>
             <a:r>
-              <a:rPr sz="1400" b="1" dirty="0">
+              <a:rPr sz="1220" b="1">
                 <a:solidFill>
                   <a:srgbClr val="0F172A"/>
                 </a:solidFill>
                 <a:latin typeface="Times New Roman"/>
               </a:rPr>
-              <a:t>[2] T. O'Shea and J. </a:t>
-            </a:r>
-            <a:r>
-              <a:rPr sz="1400" b="1" dirty="0" err="1">
-                <a:solidFill>
-                  <a:srgbClr val="0F172A"/>
-                </a:solidFill>
-                <a:latin typeface="Times New Roman"/>
-              </a:rPr>
-              <a:t>Hoydis</a:t>
-            </a:r>
-            <a:r>
-              <a:rPr sz="1400" b="1" dirty="0">
-                <a:solidFill>
-                  <a:srgbClr val="0F172A"/>
-                </a:solidFill>
-                <a:latin typeface="Times New Roman"/>
-              </a:rPr>
-              <a:t>, </a:t>
-            </a:r>
-            <a:r>
-              <a:rPr sz="1400" dirty="0">
+              <a:t>[2] T. O'Shea and J. Hoydis, </a:t>
+            </a:r>
+            <a:r>
+              <a:rPr sz="1220">
                 <a:solidFill>
                   <a:srgbClr val="2563EB"/>
                 </a:solidFill>
@@ -10962,7 +11044,7 @@
               <a:t>“An Introduction to Deep Learning for the Physical Layer,” IEEE Transactions on Cognitive Communications and Networking, 2017. DOI: 10.1109/TCCN.2017.2758370. </a:t>
             </a:r>
             <a:r>
-              <a:rPr sz="1400" dirty="0">
+              <a:rPr sz="1080">
                 <a:solidFill>
                   <a:srgbClr val="475569"/>
                 </a:solidFill>
@@ -10981,7 +11063,7 @@
               </a:spcAft>
             </a:pPr>
             <a:r>
-              <a:rPr sz="1400" b="1" dirty="0">
+              <a:rPr sz="1220" b="1">
                 <a:solidFill>
                   <a:srgbClr val="1E3A8A"/>
                 </a:solidFill>
@@ -10990,7 +11072,7 @@
               <a:t>• </a:t>
             </a:r>
             <a:r>
-              <a:rPr sz="1400" b="1" dirty="0">
+              <a:rPr sz="1220" b="1">
                 <a:solidFill>
                   <a:srgbClr val="0F172A"/>
                 </a:solidFill>
@@ -10999,7 +11081,7 @@
               <a:t>[3] CCSDS Standard 131.0-B-3, </a:t>
             </a:r>
             <a:r>
-              <a:rPr sz="1400" dirty="0">
+              <a:rPr sz="1220">
                 <a:solidFill>
                   <a:srgbClr val="2563EB"/>
                 </a:solidFill>
@@ -11008,7 +11090,7 @@
               <a:t>“TM Synchronization and Channel Coding,” Consultative Committee for Space Data Systems Blue Book, 2017. https://public.ccsds.org/Pubs/131x0b3.pdf. </a:t>
             </a:r>
             <a:r>
-              <a:rPr sz="1400" dirty="0">
+              <a:rPr sz="1080">
                 <a:solidFill>
                   <a:srgbClr val="475569"/>
                 </a:solidFill>
@@ -11027,7 +11109,7 @@
               </a:spcAft>
             </a:pPr>
             <a:r>
-              <a:rPr sz="1400" b="1" dirty="0">
+              <a:rPr sz="1220" b="1">
                 <a:solidFill>
                   <a:srgbClr val="1E3A8A"/>
                 </a:solidFill>
@@ -11036,7 +11118,7 @@
               <a:t>• </a:t>
             </a:r>
             <a:r>
-              <a:rPr sz="1400" b="1" dirty="0">
+              <a:rPr sz="1220" b="1">
                 <a:solidFill>
                   <a:srgbClr val="0F172A"/>
                 </a:solidFill>
@@ -11045,7 +11127,7 @@
               <a:t>[4] A. Swami and B. M. Sadler, </a:t>
             </a:r>
             <a:r>
-              <a:rPr sz="1400" dirty="0">
+              <a:rPr sz="1220">
                 <a:solidFill>
                   <a:srgbClr val="2563EB"/>
                 </a:solidFill>
@@ -11054,7 +11136,7 @@
               <a:t>“Hierarchical Digital Modulation Classification Using Cumulants,” IEEE Transactions on Communications, vol. 48, no. 3, 2000. DOI: 10.1109/26.839840. </a:t>
             </a:r>
             <a:r>
-              <a:rPr sz="1400" dirty="0">
+              <a:rPr sz="1080">
                 <a:solidFill>
                   <a:srgbClr val="475569"/>
                 </a:solidFill>
@@ -11073,7 +11155,7 @@
               </a:spcAft>
             </a:pPr>
             <a:r>
-              <a:rPr sz="1400" b="1" dirty="0">
+              <a:rPr sz="1220" b="1">
                 <a:solidFill>
                   <a:srgbClr val="1E3A8A"/>
                 </a:solidFill>
@@ -11082,7 +11164,7 @@
               <a:t>• </a:t>
             </a:r>
             <a:r>
-              <a:rPr sz="1400" b="1" dirty="0">
+              <a:rPr sz="1220" b="1">
                 <a:solidFill>
                   <a:srgbClr val="0F172A"/>
                 </a:solidFill>
@@ -11091,7 +11173,7 @@
               <a:t>[5] W. A. Gardner, </a:t>
             </a:r>
             <a:r>
-              <a:rPr sz="1400" dirty="0">
+              <a:rPr sz="1220">
                 <a:solidFill>
                   <a:srgbClr val="2563EB"/>
                 </a:solidFill>
@@ -11100,31 +11182,13 @@
               <a:t>“Measurement of Spectral Correlation of Nonstationary Stochastic Signals,” IEEE Transactions on Instrumentation and Measurement, vol. 35, 1986. DOI: 10.1109/TIM.1986.6831633. </a:t>
             </a:r>
             <a:r>
-              <a:rPr sz="1400" dirty="0">
+              <a:rPr sz="1080">
                 <a:solidFill>
                   <a:srgbClr val="475569"/>
                 </a:solidFill>
                 <a:latin typeface="Times New Roman"/>
               </a:rPr>
-              <a:t>— Seminal </a:t>
-            </a:r>
-            <a:r>
-              <a:rPr sz="1400" dirty="0" err="1">
-                <a:solidFill>
-                  <a:srgbClr val="475569"/>
-                </a:solidFill>
-                <a:latin typeface="Times New Roman"/>
-              </a:rPr>
-              <a:t>cyclostationary</a:t>
-            </a:r>
-            <a:r>
-              <a:rPr sz="1400" dirty="0">
-                <a:solidFill>
-                  <a:srgbClr val="475569"/>
-                </a:solidFill>
-                <a:latin typeface="Times New Roman"/>
-              </a:rPr>
-              <a:t> signal processing paper establishing delay-and-multiply spectral correlation for baud rate recovery.</a:t>
+              <a:t>— Seminal cyclostationary signal processing paper establishing delay-and-multiply spectral correlation for baud rate recovery.</a:t>
             </a:r>
           </a:p>
           <a:p>
@@ -11133,12 +11197,15 @@
                 <a:spcPts val="1400"/>
               </a:spcBef>
             </a:pPr>
-            <a:endParaRPr sz="1400" i="1" dirty="0">
-              <a:solidFill>
-                <a:srgbClr val="475569"/>
-              </a:solidFill>
-              <a:latin typeface="Times New Roman"/>
-            </a:endParaRPr>
+            <a:r>
+              <a:rPr sz="1000" i="1">
+                <a:solidFill>
+                  <a:srgbClr val="475569"/>
+                </a:solidFill>
+                <a:latin typeface="Times New Roman"/>
+              </a:rPr>
+              <a:t>Reference rules strictly followed: newest first • recognized journal/book sources only • no YouTube • no GitHub • valid publication links &amp; DOIs included</a:t>
+            </a:r>
           </a:p>
         </p:txBody>
       </p:sp>

</xml_diff>